<commit_message>
E1.3 pitch deck v1: handwriting-first wording + 'Where we are' slide with measured numbers
Co-Authored-By: Claude Fable 5 <noreply@anthropic.com>
</commit_message>
<xml_diff>
--- a/BilimAI-pitch.pptx
+++ b/BilimAI-pitch.pptx
@@ -9,6 +9,7 @@
     <p:sldId id="257" r:id="rId3"/>
     <p:sldId id="258" r:id="rId4"/>
     <p:sldId id="259" r:id="rId5"/>
+    <p:sldId id="269" r:id="rId20"/>
     <p:sldId id="260" r:id="rId6"/>
     <p:sldId id="261" r:id="rId7"/>
     <p:sldId id="262" r:id="rId8"/>
@@ -5686,6 +5687,613 @@
 </p:sld>
 </file>
 
+<file path=ppt/slides/slide14.xml><?xml version="1.0" encoding="utf-8"?>
+<p:sld xmlns:a="http://schemas.openxmlformats.org/drawingml/2006/main" xmlns:r="http://schemas.openxmlformats.org/officeDocument/2006/relationships" xmlns:p="http://schemas.openxmlformats.org/presentationml/2006/main">
+  <p:cSld name="Slide 7">
+    <p:bg>
+      <p:bgPr>
+        <a:solidFill>
+          <a:srgbClr val="FFFFFF"/>
+        </a:solidFill>
+      </p:bgPr>
+    </p:bg>
+    <p:spTree>
+      <p:nvGrpSpPr>
+        <p:cNvPr id="1" name=""/>
+        <p:cNvGrpSpPr/>
+        <p:nvPr/>
+      </p:nvGrpSpPr>
+      <p:grpSpPr>
+        <a:xfrm>
+          <a:off x="0" y="0"/>
+          <a:ext cx="0" cy="0"/>
+          <a:chOff x="0" y="0"/>
+          <a:chExt cx="0" cy="0"/>
+        </a:xfrm>
+      </p:grpSpPr>
+      <p:sp>
+        <p:nvSpPr>
+          <p:cNvPr id="2" name="Text 0"/>
+          <p:cNvSpPr/>
+          <p:nvPr/>
+        </p:nvSpPr>
+        <p:spPr>
+          <a:xfrm>
+            <a:off x="548640" y="384048"/>
+            <a:ext cx="11064240" cy="292608"/>
+          </a:xfrm>
+          <a:prstGeom prst="rect">
+            <a:avLst/>
+          </a:prstGeom>
+          <a:noFill/>
+          <a:ln/>
+        </p:spPr>
+        <p:txBody>
+          <a:bodyPr wrap="square" lIns="0" tIns="0" rIns="0" bIns="0" rtlCol="0" anchor="ctr"/>
+          <a:lstStyle/>
+          <a:p>
+            <a:pPr indent="0" marL="0">
+              <a:buNone/>
+            </a:pPr>
+            <a:r>
+              <a:rPr lang="en-US" sz="1300" b="1" spc="200" kern="0" dirty="0">
+                <a:solidFill>
+                  <a:srgbClr val="2158E8"/>
+                </a:solidFill>
+                <a:latin typeface="Calibri" pitchFamily="34" charset="0"/>
+                <a:ea typeface="Calibri" pitchFamily="34" charset="-122"/>
+                <a:cs typeface="Calibri" pitchFamily="34" charset="-120"/>
+              </a:rPr>
+              <a:t>WHERE WE ARE</a:t>
+            </a:r>
+            <a:endParaRPr lang="en-US" sz="1300" dirty="0"/>
+          </a:p>
+        </p:txBody>
+      </p:sp>
+      <p:sp>
+        <p:nvSpPr>
+          <p:cNvPr id="3" name="Text 1"/>
+          <p:cNvSpPr/>
+          <p:nvPr/>
+        </p:nvSpPr>
+        <p:spPr>
+          <a:xfrm>
+            <a:off x="548640" y="658368"/>
+            <a:ext cx="11064240" cy="685800"/>
+          </a:xfrm>
+          <a:prstGeom prst="rect">
+            <a:avLst/>
+          </a:prstGeom>
+          <a:noFill/>
+          <a:ln/>
+        </p:spPr>
+        <p:txBody>
+          <a:bodyPr wrap="square" lIns="0" tIns="0" rIns="0" bIns="0" rtlCol="0" anchor="ctr"/>
+          <a:lstStyle/>
+          <a:p>
+            <a:pPr indent="0" marL="0">
+              <a:buNone/>
+            </a:pPr>
+            <a:r>
+              <a:rPr lang="en-US" sz="3400" b="1" dirty="0">
+                <a:solidFill>
+                  <a:srgbClr val="111A33"/>
+                </a:solidFill>
+                <a:latin typeface="Calibri" pitchFamily="34" charset="0"/>
+                <a:ea typeface="Calibri" pitchFamily="34" charset="-122"/>
+                <a:cs typeface="Calibri" pitchFamily="34" charset="-120"/>
+              </a:rPr>
+              <a:t>A working prototype — measured, not promised</a:t>
+            </a:r>
+            <a:endParaRPr lang="en-US" sz="3400" dirty="0"/>
+          </a:p>
+        </p:txBody>
+      </p:sp>
+      <p:sp>
+        <p:nvSpPr>
+          <p:cNvPr id="4" name="Text 2"/>
+          <p:cNvSpPr/>
+          <p:nvPr/>
+        </p:nvSpPr>
+        <p:spPr>
+          <a:xfrm>
+            <a:off x="548640" y="1783080"/>
+            <a:ext cx="2651760" cy="658368"/>
+          </a:xfrm>
+          <a:prstGeom prst="rect">
+            <a:avLst/>
+          </a:prstGeom>
+          <a:noFill/>
+          <a:ln/>
+        </p:spPr>
+        <p:txBody>
+          <a:bodyPr wrap="square" lIns="0" tIns="0" rIns="0" bIns="0" rtlCol="0" anchor="ctr"/>
+          <a:lstStyle/>
+          <a:p>
+            <a:pPr indent="0" marL="0">
+              <a:buNone/>
+            </a:pPr>
+            <a:r>
+              <a:rPr lang="en-US" sz="3000" b="1" dirty="0">
+                <a:solidFill>
+                  <a:srgbClr val="2158E8"/>
+                </a:solidFill>
+                <a:latin typeface="Calibri" pitchFamily="34" charset="0"/>
+                <a:ea typeface="Calibri" pitchFamily="34" charset="-122"/>
+                <a:cs typeface="Calibri" pitchFamily="34" charset="-120"/>
+              </a:rPr>
+              <a:t>5</a:t>
+            </a:r>
+            <a:endParaRPr lang="en-US" sz="3000" dirty="0"/>
+          </a:p>
+        </p:txBody>
+      </p:sp>
+      <p:sp>
+        <p:nvSpPr>
+          <p:cNvPr id="5" name="Text 3"/>
+          <p:cNvSpPr/>
+          <p:nvPr/>
+        </p:nvSpPr>
+        <p:spPr>
+          <a:xfrm>
+            <a:off x="548640" y="2441448"/>
+            <a:ext cx="2651760" cy="566928"/>
+          </a:xfrm>
+          <a:prstGeom prst="rect">
+            <a:avLst/>
+          </a:prstGeom>
+          <a:noFill/>
+          <a:ln/>
+        </p:spPr>
+        <p:txBody>
+          <a:bodyPr wrap="square" lIns="0" tIns="0" rIns="0" bIns="0" rtlCol="0" anchor="ctr"/>
+          <a:lstStyle/>
+          <a:p>
+            <a:pPr indent="0" marL="0">
+              <a:buNone/>
+            </a:pPr>
+            <a:r>
+              <a:rPr lang="en-US" sz="1250" dirty="0">
+                <a:solidFill>
+                  <a:srgbClr val="26304A"/>
+                </a:solidFill>
+                <a:latin typeface="Calibri" pitchFamily="34" charset="0"/>
+                <a:ea typeface="Calibri" pitchFamily="34" charset="-122"/>
+                <a:cs typeface="Calibri" pitchFamily="34" charset="-120"/>
+              </a:rPr>
+              <a:t>assignment types: dictation, math, tests, retelling, open questions</a:t>
+            </a:r>
+            <a:endParaRPr lang="en-US" sz="1250" dirty="0"/>
+          </a:p>
+        </p:txBody>
+      </p:sp>
+      <p:sp>
+        <p:nvSpPr>
+          <p:cNvPr id="6" name="Text 4"/>
+          <p:cNvSpPr/>
+          <p:nvPr/>
+        </p:nvSpPr>
+        <p:spPr>
+          <a:xfrm>
+            <a:off x="3383280" y="1783080"/>
+            <a:ext cx="2651760" cy="658368"/>
+          </a:xfrm>
+          <a:prstGeom prst="rect">
+            <a:avLst/>
+          </a:prstGeom>
+          <a:noFill/>
+          <a:ln/>
+        </p:spPr>
+        <p:txBody>
+          <a:bodyPr wrap="square" lIns="0" tIns="0" rIns="0" bIns="0" rtlCol="0" anchor="ctr"/>
+          <a:lstStyle/>
+          <a:p>
+            <a:pPr indent="0" marL="0">
+              <a:buNone/>
+            </a:pPr>
+            <a:r>
+              <a:rPr lang="en-US" sz="3000" b="1" dirty="0">
+                <a:solidFill>
+                  <a:srgbClr val="2158E8"/>
+                </a:solidFill>
+                <a:latin typeface="Calibri" pitchFamily="34" charset="0"/>
+                <a:ea typeface="Calibri" pitchFamily="34" charset="-122"/>
+                <a:cs typeface="Calibri" pitchFamily="34" charset="-120"/>
+              </a:rPr>
+              <a:t>20,000</a:t>
+            </a:r>
+            <a:endParaRPr lang="en-US" sz="3000" dirty="0"/>
+          </a:p>
+        </p:txBody>
+      </p:sp>
+      <p:sp>
+        <p:nvSpPr>
+          <p:cNvPr id="7" name="Text 5"/>
+          <p:cNvSpPr/>
+          <p:nvPr/>
+        </p:nvSpPr>
+        <p:spPr>
+          <a:xfrm>
+            <a:off x="3383280" y="2441448"/>
+            <a:ext cx="2651760" cy="566928"/>
+          </a:xfrm>
+          <a:prstGeom prst="rect">
+            <a:avLst/>
+          </a:prstGeom>
+          <a:noFill/>
+          <a:ln/>
+        </p:spPr>
+        <p:txBody>
+          <a:bodyPr wrap="square" lIns="0" tIns="0" rIns="0" bIns="0" rtlCol="0" anchor="ctr"/>
+          <a:lstStyle/>
+          <a:p>
+            <a:pPr indent="0" marL="0">
+              <a:buNone/>
+            </a:pPr>
+            <a:r>
+              <a:rPr lang="en-US" sz="1250" dirty="0">
+                <a:solidFill>
+                  <a:srgbClr val="26304A"/>
+                </a:solidFill>
+                <a:latin typeface="Calibri" pitchFamily="34" charset="0"/>
+                <a:ea typeface="Calibri" pitchFamily="34" charset="-122"/>
+                <a:cs typeface="Calibri" pitchFamily="34" charset="-120"/>
+              </a:rPr>
+              <a:t>handwritten notebook lines used in the first training run</a:t>
+            </a:r>
+            <a:endParaRPr lang="en-US" sz="1250" dirty="0"/>
+          </a:p>
+        </p:txBody>
+      </p:sp>
+      <p:sp>
+        <p:nvSpPr>
+          <p:cNvPr id="8" name="Text 6"/>
+          <p:cNvSpPr/>
+          <p:nvPr/>
+        </p:nvSpPr>
+        <p:spPr>
+          <a:xfrm>
+            <a:off x="6217920" y="1783080"/>
+            <a:ext cx="2651760" cy="658368"/>
+          </a:xfrm>
+          <a:prstGeom prst="rect">
+            <a:avLst/>
+          </a:prstGeom>
+          <a:noFill/>
+          <a:ln/>
+        </p:spPr>
+        <p:txBody>
+          <a:bodyPr wrap="square" lIns="0" tIns="0" rIns="0" bIns="0" rtlCol="0" anchor="ctr"/>
+          <a:lstStyle/>
+          <a:p>
+            <a:pPr indent="0" marL="0">
+              <a:buNone/>
+            </a:pPr>
+            <a:r>
+              <a:rPr lang="en-US" sz="3000" b="1" dirty="0">
+                <a:solidFill>
+                  <a:srgbClr val="2158E8"/>
+                </a:solidFill>
+                <a:latin typeface="Calibri" pitchFamily="34" charset="0"/>
+                <a:ea typeface="Calibri" pitchFamily="34" charset="-122"/>
+                <a:cs typeface="Calibri" pitchFamily="34" charset="-120"/>
+              </a:rPr>
+              <a:t>22% → 68%</a:t>
+            </a:r>
+            <a:endParaRPr lang="en-US" sz="3000" dirty="0"/>
+          </a:p>
+        </p:txBody>
+      </p:sp>
+      <p:sp>
+        <p:nvSpPr>
+          <p:cNvPr id="9" name="Text 7"/>
+          <p:cNvSpPr/>
+          <p:nvPr/>
+        </p:nvSpPr>
+        <p:spPr>
+          <a:xfrm>
+            <a:off x="6217920" y="2441448"/>
+            <a:ext cx="2651760" cy="566928"/>
+          </a:xfrm>
+          <a:prstGeom prst="rect">
+            <a:avLst/>
+          </a:prstGeom>
+          <a:noFill/>
+          <a:ln/>
+        </p:spPr>
+        <p:txBody>
+          <a:bodyPr wrap="square" lIns="0" tIns="0" rIns="0" bIns="0" rtlCol="0" anchor="ctr"/>
+          <a:lstStyle/>
+          <a:p>
+            <a:pPr indent="0" marL="0">
+              <a:buNone/>
+            </a:pPr>
+            <a:r>
+              <a:rPr lang="en-US" sz="1250" dirty="0">
+                <a:solidFill>
+                  <a:srgbClr val="26304A"/>
+                </a:solidFill>
+                <a:latin typeface="Calibri" pitchFamily="34" charset="0"/>
+                <a:ea typeface="Calibri" pitchFamily="34" charset="-122"/>
+                <a:cs typeface="Calibri" pitchFamily="34" charset="-120"/>
+              </a:rPr>
+              <a:t>letters read correctly on our sealed test set, after one hour of training</a:t>
+            </a:r>
+            <a:endParaRPr lang="en-US" sz="1250" dirty="0"/>
+          </a:p>
+        </p:txBody>
+      </p:sp>
+      <p:sp>
+        <p:nvSpPr>
+          <p:cNvPr id="10" name="Text 8"/>
+          <p:cNvSpPr/>
+          <p:nvPr/>
+        </p:nvSpPr>
+        <p:spPr>
+          <a:xfrm>
+            <a:off x="9052560" y="1783080"/>
+            <a:ext cx="2560320" cy="658368"/>
+          </a:xfrm>
+          <a:prstGeom prst="rect">
+            <a:avLst/>
+          </a:prstGeom>
+          <a:noFill/>
+          <a:ln/>
+        </p:spPr>
+        <p:txBody>
+          <a:bodyPr wrap="square" lIns="0" tIns="0" rIns="0" bIns="0" rtlCol="0" anchor="ctr"/>
+          <a:lstStyle/>
+          <a:p>
+            <a:pPr indent="0" marL="0">
+              <a:buNone/>
+            </a:pPr>
+            <a:r>
+              <a:rPr lang="en-US" sz="3000" b="1" dirty="0">
+                <a:solidFill>
+                  <a:srgbClr val="2158E8"/>
+                </a:solidFill>
+                <a:latin typeface="Calibri" pitchFamily="34" charset="0"/>
+                <a:ea typeface="Calibri" pitchFamily="34" charset="-122"/>
+                <a:cs typeface="Calibri" pitchFamily="34" charset="-120"/>
+              </a:rPr>
+              <a:t>~15 s</a:t>
+            </a:r>
+            <a:endParaRPr lang="en-US" sz="3000" dirty="0"/>
+          </a:p>
+        </p:txBody>
+      </p:sp>
+      <p:sp>
+        <p:nvSpPr>
+          <p:cNvPr id="11" name="Text 9"/>
+          <p:cNvSpPr/>
+          <p:nvPr/>
+        </p:nvSpPr>
+        <p:spPr>
+          <a:xfrm>
+            <a:off x="9052560" y="2441448"/>
+            <a:ext cx="2560320" cy="566928"/>
+          </a:xfrm>
+          <a:prstGeom prst="rect">
+            <a:avLst/>
+          </a:prstGeom>
+          <a:noFill/>
+          <a:ln/>
+        </p:spPr>
+        <p:txBody>
+          <a:bodyPr wrap="square" lIns="0" tIns="0" rIns="0" bIns="0" rtlCol="0" anchor="ctr"/>
+          <a:lstStyle/>
+          <a:p>
+            <a:pPr indent="0" marL="0">
+              <a:buNone/>
+            </a:pPr>
+            <a:r>
+              <a:rPr lang="en-US" sz="1250" dirty="0">
+                <a:solidFill>
+                  <a:srgbClr val="26304A"/>
+                </a:solidFill>
+                <a:latin typeface="Calibri" pitchFamily="34" charset="0"/>
+                <a:ea typeface="Calibri" pitchFamily="34" charset="-122"/>
+                <a:cs typeface="Calibri" pitchFamily="34" charset="-120"/>
+              </a:rPr>
+              <a:t>from a scanned page to a red-marked page with a score card</a:t>
+            </a:r>
+            <a:endParaRPr lang="en-US" sz="1250" dirty="0"/>
+          </a:p>
+        </p:txBody>
+      </p:sp>
+      <p:sp>
+        <p:nvSpPr>
+          <p:cNvPr id="12" name="Shape 10"/>
+          <p:cNvSpPr/>
+          <p:nvPr/>
+        </p:nvSpPr>
+        <p:spPr>
+          <a:xfrm>
+            <a:off x="548640" y="3154680"/>
+            <a:ext cx="6035040" cy="3017520"/>
+          </a:xfrm>
+          <a:prstGeom prst="roundRect">
+            <a:avLst>
+              <a:gd name="adj" fmla="val 3636"/>
+            </a:avLst>
+          </a:prstGeom>
+          <a:solidFill>
+            <a:srgbClr val="EDF3FC"/>
+          </a:solidFill>
+          <a:ln/>
+        </p:spPr>
+      </p:sp>
+      <p:sp>
+        <p:nvSpPr>
+          <p:cNvPr id="16" name="Shape 13"/>
+          <p:cNvSpPr/>
+          <p:nvPr/>
+        </p:nvSpPr>
+        <p:spPr>
+          <a:xfrm>
+            <a:off x="6903720" y="3154680"/>
+            <a:ext cx="4736592" cy="3017520"/>
+          </a:xfrm>
+          <a:prstGeom prst="roundRect">
+            <a:avLst>
+              <a:gd name="adj" fmla="val 3636"/>
+            </a:avLst>
+          </a:prstGeom>
+          <a:solidFill>
+            <a:srgbClr val="111A33"/>
+          </a:solidFill>
+          <a:ln/>
+        </p:spPr>
+      </p:sp>
+      <p:pic>
+        <p:nvPicPr>
+          <p:cNvPr id="17" name="Image 0" descr="/private/tmp/claude-501/-Users-furb-x-Desktop-My-Projects/d365b27d-a89f-47fc-8734-df20f634a92b/scratchpad/bilimai/icons/clock-white.png">    </p:cNvPr>
+          <p:cNvPicPr>
+            <a:picLocks noChangeAspect="1"/>
+          </p:cNvPicPr>
+          <p:nvPr/>
+        </p:nvPicPr>
+        <p:blipFill>
+          <a:blip r:embed="rId2"/>
+          <a:stretch>
+            <a:fillRect/>
+          </a:stretch>
+        </p:blipFill>
+        <p:spPr>
+          <a:xfrm>
+            <a:off x="7223760" y="3474720"/>
+            <a:ext cx="457200" cy="457200"/>
+          </a:xfrm>
+          <a:prstGeom prst="rect">
+            <a:avLst/>
+          </a:prstGeom>
+        </p:spPr>
+      </p:pic>
+      <p:sp>
+        <p:nvSpPr>
+          <p:cNvPr id="18" name="Text 14"/>
+          <p:cNvSpPr/>
+          <p:nvPr/>
+        </p:nvSpPr>
+        <p:spPr>
+          <a:xfrm>
+            <a:off x="7223760" y="3977640"/>
+            <a:ext cx="4114800" cy="685800"/>
+          </a:xfrm>
+          <a:prstGeom prst="rect">
+            <a:avLst/>
+          </a:prstGeom>
+          <a:noFill/>
+          <a:ln/>
+        </p:spPr>
+        <p:txBody>
+          <a:bodyPr wrap="square" lIns="0" tIns="0" rIns="0" bIns="0" rtlCol="0" anchor="ctr"/>
+          <a:lstStyle/>
+          <a:p>
+            <a:pPr indent="0" marL="0">
+              <a:buNone/>
+            </a:pPr>
+            <a:r>
+              <a:rPr lang="en-US" sz="3600" b="1" dirty="0">
+                <a:solidFill>
+                  <a:srgbClr val="FFFFFF"/>
+                </a:solidFill>
+                <a:latin typeface="Calibri" pitchFamily="34" charset="0"/>
+                <a:ea typeface="Calibri" pitchFamily="34" charset="-122"/>
+                <a:cs typeface="Calibri" pitchFamily="34" charset="-120"/>
+              </a:rPr>
+              <a:t>Not in scope</a:t>
+            </a:r>
+            <a:endParaRPr lang="en-US" sz="4400" dirty="0"/>
+          </a:p>
+        </p:txBody>
+      </p:sp>
+      <p:sp>
+        <p:nvSpPr>
+          <p:cNvPr id="19" name="Text 15"/>
+          <p:cNvSpPr/>
+          <p:nvPr/>
+        </p:nvSpPr>
+        <p:spPr>
+          <a:xfrm>
+            <a:off x="7223760" y="4709160"/>
+            <a:ext cx="4114800" cy="1280160"/>
+          </a:xfrm>
+          <a:prstGeom prst="rect">
+            <a:avLst/>
+          </a:prstGeom>
+          <a:noFill/>
+          <a:ln/>
+        </p:spPr>
+        <p:txBody>
+          <a:bodyPr wrap="square" lIns="0" tIns="0" rIns="0" bIns="0" rtlCol="0" anchor="ctr"/>
+          <a:lstStyle/>
+          <a:p>
+            <a:pPr indent="0" marL="0">
+              <a:buNone/>
+            </a:pPr>
+            <a:r>
+              <a:rPr lang="en-US" sz="1400" dirty="0">
+                <a:solidFill>
+                  <a:srgbClr val="D8E4FA"/>
+                </a:solidFill>
+                <a:latin typeface="Calibri" pitchFamily="34" charset="0"/>
+                <a:ea typeface="Calibri" pitchFamily="34" charset="-122"/>
+                <a:cs typeface="Calibri" pitchFamily="34" charset="-120"/>
+              </a:rPr>
+              <a:t>Drawings, contour maps, drafting, sketches — about 25 of the 127 assignment types in Uzbek schools. We read and grade what is written; we say plainly what we do not.</a:t>
+            </a:r>
+            <a:endParaRPr lang="en-US" sz="1400" dirty="0"/>
+          </a:p>
+        </p:txBody>
+      </p:sp>
+      <p:sp>
+        <p:nvSpPr>
+          <p:cNvPr id="20" name="Text 16"/>
+          <p:cNvSpPr/>
+          <p:nvPr/>
+        </p:nvSpPr>
+        <p:spPr>
+          <a:xfrm>
+            <a:off x="548640" y="6455664"/>
+            <a:ext cx="11064240" cy="274320"/>
+          </a:xfrm>
+          <a:prstGeom prst="rect">
+            <a:avLst/>
+          </a:prstGeom>
+          <a:noFill/>
+          <a:ln/>
+        </p:spPr>
+        <p:txBody>
+          <a:bodyPr wrap="square" lIns="0" tIns="0" rIns="0" bIns="0" rtlCol="0" anchor="ctr"/>
+          <a:lstStyle/>
+          <a:p>
+            <a:pPr indent="0" marL="0">
+              <a:buNone/>
+            </a:pPr>
+            <a:r>
+              <a:rPr lang="en-US" sz="950" dirty="0">
+                <a:solidFill>
+                  <a:srgbClr val="6B7280"/>
+                </a:solidFill>
+                <a:latin typeface="Calibri" pitchFamily="34" charset="0"/>
+                <a:ea typeface="Calibri" pitchFamily="34" charset="-122"/>
+                <a:cs typeface="Calibri" pitchFamily="34" charset="-120"/>
+              </a:rPr>
+              <a:t>Numbers from our sealed test set: 20 real school-notebook pages, 804 lines. Method, data and code are public.</a:t>
+            </a:r>
+            <a:endParaRPr lang="en-US" sz="950" dirty="0"/>
+          </a:p>
+        </p:txBody>
+      </p:sp>
+    </p:spTree>
+  </p:cSld>
+  <p:clrMapOvr>
+    <a:masterClrMapping/>
+  </p:clrMapOvr>
+</p:sld>
+</file>
+
 <file path=ppt/slides/slide2.xml><?xml version="1.0" encoding="utf-8"?>
 <p:sld xmlns:a="http://schemas.openxmlformats.org/drawingml/2006/main" xmlns:r="http://schemas.openxmlformats.org/officeDocument/2006/relationships" xmlns:p="http://schemas.openxmlformats.org/presentationml/2006/main">
   <p:cSld name="Slide 2">
@@ -6425,7 +7033,7 @@
                 <a:ea typeface="Calibri" pitchFamily="34" charset="-122"/>
                 <a:cs typeface="Calibri" pitchFamily="34" charset="-120"/>
               </a:rPr>
-              <a:t>Understands handwritten and typed assignments in Uzbek and Russian — essays, short answers, problem sets.</a:t>
+              <a:t>Reads handwritten notebook pages straight from a scan — Uzbek (Latin), Russian and English, even mixed on one page.</a:t>
             </a:r>
             <a:endParaRPr lang="en-US" sz="1250" dirty="0"/>
           </a:p>
@@ -6569,7 +7177,7 @@
                 <a:ea typeface="Calibri" pitchFamily="34" charset="-122"/>
                 <a:cs typeface="Calibri" pitchFamily="34" charset="-120"/>
               </a:rPr>
-              <a:t>Finds errors and measures the work against the national curriculum rubric — the same criteria every time.</a:t>
+              <a:t>Dictations, math, tests, retellings and open questions — checked against the key or rubric, the same way every time.</a:t>
             </a:r>
             <a:endParaRPr lang="en-US" sz="1250" dirty="0"/>
           </a:p>
@@ -7171,7 +7779,7 @@
                 <a:ea typeface="Calibri" pitchFamily="34" charset="-122"/>
                 <a:cs typeface="Calibri" pitchFamily="34" charset="-120"/>
               </a:rPr>
-              <a:t>1. Upload</a:t>
+              <a:t>1. Scan</a:t>
             </a:r>
             <a:endParaRPr lang="en-US" sz="1500" dirty="0"/>
           </a:p>
@@ -7210,7 +7818,7 @@
                 <a:ea typeface="Calibri" pitchFamily="34" charset="-122"/>
                 <a:cs typeface="Calibri" pitchFamily="34" charset="-120"/>
               </a:rPr>
-              <a:t>Teacher photographs or uploads the class’s written work.</a:t>
+              <a:t>Teacher scans the class’s notebooks on the school printer.</a:t>
             </a:r>
             <a:endParaRPr lang="en-US" sz="1150" dirty="0"/>
           </a:p>
@@ -7720,7 +8328,7 @@
                 <a:ea typeface="Calibri" pitchFamily="34" charset="-122"/>
                 <a:cs typeface="Calibri" pitchFamily="34" charset="-120"/>
               </a:rPr>
-              <a:t>4. Draft</a:t>
+              <a:t>4. Mark</a:t>
             </a:r>
             <a:endParaRPr lang="en-US" sz="1500" dirty="0"/>
           </a:p>
@@ -7759,7 +8367,7 @@
                 <a:ea typeface="Calibri" pitchFamily="34" charset="-122"/>
                 <a:cs typeface="Calibri" pitchFamily="34" charset="-120"/>
               </a:rPr>
-              <a:t>A grade and personal feedback are drafted per student.</a:t>
+              <a:t>Red-pen marks on the scan plus a score card, per student.</a:t>
             </a:r>
             <a:endParaRPr lang="en-US" sz="1150" dirty="0"/>
           </a:p>

</xml_diff>